<commit_message>
update initial presentation deck
</commit_message>
<xml_diff>
--- a/deliverables/final_solution_2026_06_24/RS小组演讲ppt.pptx
+++ b/deliverables/final_solution_2026_06_24/RS小组演讲ppt.pptx
@@ -117,6 +117,11 @@
       </a:defRPr>
     </a:lvl9pPr>
   </p:defaultTextStyle>
+  <p:extLst>
+    <p:ext uri="{EFAFB233-063F-42B5-8137-9DF3F51BA10A}">
+      <p15:sldGuideLst xmlns:p15="http://schemas.microsoft.com/office/powerpoint/2012/main"/>
+    </p:ext>
+  </p:extLst>
 </p:presentation>
 </file>
 
@@ -3649,7 +3654,7 @@
         </p:nvSpPr>
         <p:spPr>
           <a:xfrm>
-            <a:off x="6477000" y="1619250"/>
+            <a:off x="6132870" y="1616177"/>
             <a:ext cx="2381250" cy="323850"/>
           </a:xfrm>
           <a:prstGeom prst="rect">
@@ -3704,8 +3709,8 @@
         </p:nvSpPr>
         <p:spPr>
           <a:xfrm>
-            <a:off x="6477000" y="2095500"/>
-            <a:ext cx="4572000" cy="1809750"/>
+            <a:off x="6096000" y="2105025"/>
+            <a:ext cx="6059130" cy="1809750"/>
           </a:xfrm>
           <a:prstGeom prst="rect">
             <a:avLst/>
@@ -3785,6 +3790,56 @@
                 </a:solidFill>
               </a:rPr>
               <a:t>• Perform time-aware calibration for campaign drift</a:t>
+            </a:r>
+          </a:p>
+          <a:p>
+            <a:pPr>
+              <a:defRPr sz="1500" b="0">
+                <a:solidFill>
+                  <a:srgbClr val="18212B"/>
+                </a:solidFill>
+              </a:defRPr>
+            </a:pPr>
+            <a:r>
+              <a:rPr lang="en-US" altLang="zh-CN" sz="1500" dirty="0">
+                <a:solidFill>
+                  <a:srgbClr val="18212B"/>
+                </a:solidFill>
+              </a:rPr>
+              <a:t>• </a:t>
+            </a:r>
+            <a:r>
+              <a:rPr lang="en-US" sz="1500" dirty="0">
+                <a:solidFill>
+                  <a:srgbClr val="18212B"/>
+                </a:solidFill>
+              </a:rPr>
+              <a:t>Provide feedback on consumer preferences </a:t>
+            </a:r>
+          </a:p>
+          <a:p>
+            <a:pPr>
+              <a:defRPr sz="1500" b="0">
+                <a:solidFill>
+                  <a:srgbClr val="18212B"/>
+                </a:solidFill>
+              </a:defRPr>
+            </a:pPr>
+            <a:r>
+              <a:rPr lang="en-US" altLang="zh-CN" sz="1500" dirty="0">
+                <a:solidFill>
+                  <a:srgbClr val="18212B"/>
+                </a:solidFill>
+              </a:rPr>
+              <a:t>• E</a:t>
+            </a:r>
+            <a:r>
+              <a:rPr lang="en-US" sz="1500" dirty="0">
+                <a:solidFill>
+                  <a:srgbClr val="18212B"/>
+                </a:solidFill>
+              </a:rPr>
+              <a:t>xplanations for the reasons behind recommendations</a:t>
             </a:r>
             <a:endParaRPr sz="1500" b="0" dirty="0">
               <a:solidFill>
@@ -9698,7 +9753,23 @@
                   <a:srgbClr val="18212B"/>
                 </a:solidFill>
               </a:rPr>
-              <a:t>• Business Utility proxy is used to explain marketing constraints and is not regarded as the final primary indicator</a:t>
+              <a:t>• Business Utility proxy </a:t>
+            </a:r>
+            <a:r>
+              <a:rPr lang="en-US" altLang="zh-CN" sz="1575" dirty="0">
+                <a:solidFill>
+                  <a:srgbClr val="18212B"/>
+                </a:solidFill>
+              </a:rPr>
+              <a:t>can </a:t>
+            </a:r>
+            <a:r>
+              <a:rPr lang="en-US" sz="1575" dirty="0">
+                <a:solidFill>
+                  <a:srgbClr val="18212B"/>
+                </a:solidFill>
+              </a:rPr>
+              <a:t>explain marketing constraints</a:t>
             </a:r>
             <a:endParaRPr sz="1575" b="0" dirty="0">
               <a:solidFill>

</xml_diff>